<commit_message>
.\Python\Lesson 05 - File IO"
</commit_message>
<xml_diff>
--- a/Python/Lesson 05 - File IO/Python File IO.pptx
+++ b/Python/Lesson 05 - File IO/Python File IO.pptx
@@ -225,7 +225,7 @@
           <a:p>
             <a:fld id="{941F8BC1-DC94-491B-AA44-0232F744EE98}" type="datetimeFigureOut">
               <a:rPr lang="en-US" smtClean="0"/>
-              <a:t>7/21/2026</a:t>
+              <a:t>7/22/2026</a:t>
             </a:fld>
             <a:endParaRPr lang="en-US"/>
           </a:p>
@@ -875,7 +875,166 @@
           <a:bodyPr/>
           <a:lstStyle/>
           <a:p>
+            <a:r>
+              <a:rPr lang="en-US" dirty="0"/>
+              <a:t>‘with open’ opens a context manager</a:t>
+            </a:r>
+          </a:p>
+          <a:p>
+            <a:r>
+              <a:rPr lang="en-US" dirty="0"/>
+              <a:t> - Must be in the same directory your python is in. </a:t>
+            </a:r>
+          </a:p>
+          <a:p>
             <a:endParaRPr lang="en-US" dirty="0"/>
+          </a:p>
+          <a:p>
+            <a:endParaRPr lang="en-US" dirty="0"/>
+          </a:p>
+          <a:p>
+            <a:r>
+              <a:rPr lang="en-US" dirty="0" err="1"/>
+              <a:t>readlines</a:t>
+            </a:r>
+            <a:r>
+              <a:rPr lang="en-US" dirty="0"/>
+              <a:t> creates an actual list of all the lines in the file</a:t>
+            </a:r>
+          </a:p>
+          <a:p>
+            <a:endParaRPr lang="en-US" dirty="0"/>
+          </a:p>
+          <a:p>
+            <a:r>
+              <a:rPr lang="en-US" dirty="0"/>
+              <a:t>‘r’ = read into file </a:t>
+            </a:r>
+          </a:p>
+          <a:p>
+            <a:endParaRPr lang="en-US" dirty="0"/>
+          </a:p>
+          <a:p>
+            <a:r>
+              <a:rPr lang="en-US" dirty="0"/>
+              <a:t>‘w’ = writes into the file</a:t>
+            </a:r>
+          </a:p>
+          <a:p>
+            <a:endParaRPr lang="en-US" dirty="0"/>
+          </a:p>
+          <a:p>
+            <a:r>
+              <a:rPr lang="en-US" dirty="0"/>
+              <a:t>‘a’ = append, will add lines to the end</a:t>
+            </a:r>
+          </a:p>
+        </p:txBody>
+      </p:sp>
+      <p:sp>
+        <p:nvSpPr>
+          <p:cNvPr id="4" name="Slide Number Placeholder 3"/>
+          <p:cNvSpPr>
+            <a:spLocks noGrp="1"/>
+          </p:cNvSpPr>
+          <p:nvPr>
+            <p:ph type="sldNum" sz="quarter" idx="5"/>
+          </p:nvPr>
+        </p:nvSpPr>
+        <p:spPr/>
+        <p:txBody>
+          <a:bodyPr/>
+          <a:lstStyle/>
+          <a:p>
+            <a:fld id="{2D8B709C-82E0-4ADF-BDA3-CCA1C8B22229}" type="slidenum">
+              <a:rPr lang="en-US" smtClean="0"/>
+              <a:t>13</a:t>
+            </a:fld>
+            <a:endParaRPr lang="en-US"/>
+          </a:p>
+        </p:txBody>
+      </p:sp>
+    </p:spTree>
+    <p:extLst>
+      <p:ext uri="{BB962C8B-B14F-4D97-AF65-F5344CB8AC3E}">
+        <p14:creationId xmlns:p14="http://schemas.microsoft.com/office/powerpoint/2010/main" val="3424396193"/>
+      </p:ext>
+    </p:extLst>
+  </p:cSld>
+  <p:clrMapOvr>
+    <a:masterClrMapping/>
+  </p:clrMapOvr>
+</p:notes>
+</file>
+
+<file path=ppt/notesSlides/notesSlide13.xml><?xml version="1.0" encoding="utf-8"?>
+<p:notes xmlns:a="http://schemas.openxmlformats.org/drawingml/2006/main" xmlns:r="http://schemas.openxmlformats.org/officeDocument/2006/relationships" xmlns:p="http://schemas.openxmlformats.org/presentationml/2006/main">
+  <p:cSld>
+    <p:spTree>
+      <p:nvGrpSpPr>
+        <p:cNvPr id="1" name=""/>
+        <p:cNvGrpSpPr/>
+        <p:nvPr/>
+      </p:nvGrpSpPr>
+      <p:grpSpPr>
+        <a:xfrm>
+          <a:off x="0" y="0"/>
+          <a:ext cx="0" cy="0"/>
+          <a:chOff x="0" y="0"/>
+          <a:chExt cx="0" cy="0"/>
+        </a:xfrm>
+      </p:grpSpPr>
+      <p:sp>
+        <p:nvSpPr>
+          <p:cNvPr id="2" name="Slide Image Placeholder 1"/>
+          <p:cNvSpPr>
+            <a:spLocks noGrp="1" noRot="1" noChangeAspect="1"/>
+          </p:cNvSpPr>
+          <p:nvPr>
+            <p:ph type="sldImg"/>
+          </p:nvPr>
+        </p:nvSpPr>
+        <p:spPr/>
+      </p:sp>
+      <p:sp>
+        <p:nvSpPr>
+          <p:cNvPr id="3" name="Notes Placeholder 2"/>
+          <p:cNvSpPr>
+            <a:spLocks noGrp="1"/>
+          </p:cNvSpPr>
+          <p:nvPr>
+            <p:ph type="body" idx="1"/>
+          </p:nvPr>
+        </p:nvSpPr>
+        <p:spPr/>
+        <p:txBody>
+          <a:bodyPr/>
+          <a:lstStyle/>
+          <a:p>
+            <a:r>
+              <a:rPr lang="en-US" dirty="0"/>
+              <a:t>**Older way** is the </a:t>
+            </a:r>
+            <a:r>
+              <a:rPr lang="en-US" dirty="0" err="1"/>
+              <a:t>file_handle</a:t>
+            </a:r>
+            <a:r>
+              <a:rPr lang="en-US" dirty="0"/>
+              <a:t> (17-19)</a:t>
+            </a:r>
+          </a:p>
+          <a:p>
+            <a:endParaRPr lang="en-US" dirty="0"/>
+          </a:p>
+          <a:p>
+            <a:endParaRPr lang="en-US" dirty="0"/>
+          </a:p>
+          <a:p>
+            <a:r>
+              <a:rPr lang="en-US" dirty="0"/>
+              <a:t>‘with open’ is the newer way and best practice now</a:t>
+            </a:r>
           </a:p>
         </p:txBody>
       </p:sp>
@@ -1321,7 +1480,10 @@
           <a:bodyPr/>
           <a:lstStyle/>
           <a:p>
-            <a:endParaRPr lang="en-US" dirty="0"/>
+            <a:r>
+              <a:rPr lang="en-US" dirty="0"/>
+              <a:t>Recycle or reuse code</a:t>
+            </a:r>
           </a:p>
         </p:txBody>
       </p:sp>
@@ -1434,6 +1596,15 @@
           <a:bodyPr/>
           <a:lstStyle/>
           <a:p>
+            <a:r>
+              <a:rPr lang="en-US" dirty="0"/>
+              <a:t>Give it a label (def) and a call and that is how we define and use our function </a:t>
+            </a:r>
+          </a:p>
+          <a:p>
+            <a:endParaRPr lang="en-US" dirty="0"/>
+          </a:p>
+          <a:p>
             <a:endParaRPr lang="en-US" dirty="0"/>
           </a:p>
         </p:txBody>
@@ -1848,7 +2019,7 @@
           <a:p>
             <a:fld id="{971AFA9C-17DA-4726-B9E3-ADECF7729AF7}" type="datetimeFigureOut">
               <a:rPr lang="en-US" smtClean="0"/>
-              <a:t>7/21/2026</a:t>
+              <a:t>7/22/2026</a:t>
             </a:fld>
             <a:endParaRPr lang="en-US"/>
           </a:p>
@@ -4468,7 +4639,7 @@
           <a:p>
             <a:fld id="{971AFA9C-17DA-4726-B9E3-ADECF7729AF7}" type="datetimeFigureOut">
               <a:rPr lang="en-US" smtClean="0"/>
-              <a:t>7/21/2026</a:t>
+              <a:t>7/22/2026</a:t>
             </a:fld>
             <a:endParaRPr lang="en-US"/>
           </a:p>
@@ -6212,7 +6383,7 @@
           <a:p>
             <a:fld id="{971AFA9C-17DA-4726-B9E3-ADECF7729AF7}" type="datetimeFigureOut">
               <a:rPr lang="en-US" smtClean="0"/>
-              <a:t>7/21/2026</a:t>
+              <a:t>7/22/2026</a:t>
             </a:fld>
             <a:endParaRPr lang="en-US"/>
           </a:p>
@@ -8056,7 +8227,7 @@
           <a:p>
             <a:fld id="{971AFA9C-17DA-4726-B9E3-ADECF7729AF7}" type="datetimeFigureOut">
               <a:rPr lang="en-US" smtClean="0"/>
-              <a:t>7/21/2026</a:t>
+              <a:t>7/22/2026</a:t>
             </a:fld>
             <a:endParaRPr lang="en-US"/>
           </a:p>
@@ -8261,7 +8432,7 @@
           <a:p>
             <a:fld id="{971AFA9C-17DA-4726-B9E3-ADECF7729AF7}" type="datetimeFigureOut">
               <a:rPr lang="en-US" smtClean="0"/>
-              <a:t>7/21/2026</a:t>
+              <a:t>7/22/2026</a:t>
             </a:fld>
             <a:endParaRPr lang="en-US"/>
           </a:p>
@@ -8509,7 +8680,7 @@
           <a:p>
             <a:fld id="{971AFA9C-17DA-4726-B9E3-ADECF7729AF7}" type="datetimeFigureOut">
               <a:rPr lang="en-US" smtClean="0"/>
-              <a:t>7/21/2026</a:t>
+              <a:t>7/22/2026</a:t>
             </a:fld>
             <a:endParaRPr lang="en-US"/>
           </a:p>
@@ -8826,7 +8997,7 @@
           <a:p>
             <a:fld id="{971AFA9C-17DA-4726-B9E3-ADECF7729AF7}" type="datetimeFigureOut">
               <a:rPr lang="en-US" smtClean="0"/>
-              <a:t>7/21/2026</a:t>
+              <a:t>7/22/2026</a:t>
             </a:fld>
             <a:endParaRPr lang="en-US"/>
           </a:p>
@@ -9479,7 +9650,7 @@
           <a:p>
             <a:fld id="{971AFA9C-17DA-4726-B9E3-ADECF7729AF7}" type="datetimeFigureOut">
               <a:rPr lang="en-US" smtClean="0"/>
-              <a:t>7/21/2026</a:t>
+              <a:t>7/22/2026</a:t>
             </a:fld>
             <a:endParaRPr lang="en-US"/>
           </a:p>
@@ -10389,7 +10560,7 @@
           <a:p>
             <a:fld id="{971AFA9C-17DA-4726-B9E3-ADECF7729AF7}" type="datetimeFigureOut">
               <a:rPr lang="en-US" smtClean="0"/>
-              <a:t>7/21/2026</a:t>
+              <a:t>7/22/2026</a:t>
             </a:fld>
             <a:endParaRPr lang="en-US"/>
           </a:p>
@@ -11551,7 +11722,7 @@
           <a:p>
             <a:fld id="{971AFA9C-17DA-4726-B9E3-ADECF7729AF7}" type="datetimeFigureOut">
               <a:rPr lang="en-US" smtClean="0"/>
-              <a:t>7/21/2026</a:t>
+              <a:t>7/22/2026</a:t>
             </a:fld>
             <a:endParaRPr lang="en-US"/>
           </a:p>
@@ -11861,7 +12032,7 @@
           <a:p>
             <a:fld id="{971AFA9C-17DA-4726-B9E3-ADECF7729AF7}" type="datetimeFigureOut">
               <a:rPr lang="en-US" smtClean="0"/>
-              <a:t>7/21/2026</a:t>
+              <a:t>7/22/2026</a:t>
             </a:fld>
             <a:endParaRPr lang="en-US"/>
           </a:p>
@@ -12133,7 +12304,7 @@
           <a:p>
             <a:fld id="{971AFA9C-17DA-4726-B9E3-ADECF7729AF7}" type="datetimeFigureOut">
               <a:rPr lang="en-US" smtClean="0"/>
-              <a:t>7/21/2026</a:t>
+              <a:t>7/22/2026</a:t>
             </a:fld>
             <a:endParaRPr lang="en-US"/>
           </a:p>
@@ -13948,7 +14119,7 @@
           <a:p>
             <a:fld id="{971AFA9C-17DA-4726-B9E3-ADECF7729AF7}" type="datetimeFigureOut">
               <a:rPr lang="en-US" smtClean="0"/>
-              <a:t>7/21/2026</a:t>
+              <a:t>7/22/2026</a:t>
             </a:fld>
             <a:endParaRPr lang="en-US"/>
           </a:p>
@@ -14282,7 +14453,7 @@
           <a:p>
             <a:fld id="{971AFA9C-17DA-4726-B9E3-ADECF7729AF7}" type="datetimeFigureOut">
               <a:rPr lang="en-US" smtClean="0"/>
-              <a:t>7/21/2026</a:t>
+              <a:t>7/22/2026</a:t>
             </a:fld>
             <a:endParaRPr lang="en-US"/>
           </a:p>
@@ -14582,7 +14753,7 @@
           <a:p>
             <a:fld id="{971AFA9C-17DA-4726-B9E3-ADECF7729AF7}" type="datetimeFigureOut">
               <a:rPr lang="en-US" smtClean="0"/>
-              <a:t>7/21/2026</a:t>
+              <a:t>7/22/2026</a:t>
             </a:fld>
             <a:endParaRPr lang="en-US"/>
           </a:p>
@@ -14882,7 +15053,7 @@
           <a:p>
             <a:fld id="{971AFA9C-17DA-4726-B9E3-ADECF7729AF7}" type="datetimeFigureOut">
               <a:rPr lang="en-US" smtClean="0"/>
-              <a:t>7/21/2026</a:t>
+              <a:t>7/22/2026</a:t>
             </a:fld>
             <a:endParaRPr lang="en-US"/>
           </a:p>
@@ -15424,7 +15595,7 @@
           <a:p>
             <a:fld id="{971AFA9C-17DA-4726-B9E3-ADECF7729AF7}" type="datetimeFigureOut">
               <a:rPr lang="en-US" smtClean="0"/>
-              <a:t>7/21/2026</a:t>
+              <a:t>7/22/2026</a:t>
             </a:fld>
             <a:endParaRPr lang="en-US"/>
           </a:p>
@@ -15574,7 +15745,7 @@
           <a:p>
             <a:fld id="{971AFA9C-17DA-4726-B9E3-ADECF7729AF7}" type="datetimeFigureOut">
               <a:rPr lang="en-US" smtClean="0"/>
-              <a:t>7/21/2026</a:t>
+              <a:t>7/22/2026</a:t>
             </a:fld>
             <a:endParaRPr lang="en-US"/>
           </a:p>
@@ -15732,7 +15903,7 @@
           <a:p>
             <a:fld id="{971AFA9C-17DA-4726-B9E3-ADECF7729AF7}" type="datetimeFigureOut">
               <a:rPr lang="en-US" smtClean="0"/>
-              <a:t>7/21/2026</a:t>
+              <a:t>7/22/2026</a:t>
             </a:fld>
             <a:endParaRPr lang="en-US"/>
           </a:p>
@@ -15999,7 +16170,7 @@
           <a:p>
             <a:fld id="{971AFA9C-17DA-4726-B9E3-ADECF7729AF7}" type="datetimeFigureOut">
               <a:rPr lang="en-US" smtClean="0"/>
-              <a:t>7/21/2026</a:t>
+              <a:t>7/22/2026</a:t>
             </a:fld>
             <a:endParaRPr lang="en-US"/>
           </a:p>
@@ -16127,7 +16298,7 @@
           <a:p>
             <a:fld id="{971AFA9C-17DA-4726-B9E3-ADECF7729AF7}" type="datetimeFigureOut">
               <a:rPr lang="en-US" smtClean="0"/>
-              <a:t>7/21/2026</a:t>
+              <a:t>7/22/2026</a:t>
             </a:fld>
             <a:endParaRPr lang="en-US"/>
           </a:p>
@@ -16562,7 +16733,7 @@
           <a:p>
             <a:fld id="{971AFA9C-17DA-4726-B9E3-ADECF7729AF7}" type="datetimeFigureOut">
               <a:rPr lang="en-US" smtClean="0"/>
-              <a:t>7/21/2026</a:t>
+              <a:t>7/22/2026</a:t>
             </a:fld>
             <a:endParaRPr lang="en-US"/>
           </a:p>
@@ -16709,7 +16880,7 @@
           <a:p>
             <a:fld id="{971AFA9C-17DA-4726-B9E3-ADECF7729AF7}" type="datetimeFigureOut">
               <a:rPr lang="en-US" smtClean="0"/>
-              <a:t>7/21/2026</a:t>
+              <a:t>7/22/2026</a:t>
             </a:fld>
             <a:endParaRPr lang="en-US"/>
           </a:p>
@@ -18639,7 +18810,7 @@
           <a:p>
             <a:fld id="{971AFA9C-17DA-4726-B9E3-ADECF7729AF7}" type="datetimeFigureOut">
               <a:rPr lang="en-US" smtClean="0"/>
-              <a:t>7/21/2026</a:t>
+              <a:t>7/22/2026</a:t>
             </a:fld>
             <a:endParaRPr lang="en-US"/>
           </a:p>
@@ -18975,7 +19146,7 @@
           <a:p>
             <a:fld id="{971AFA9C-17DA-4726-B9E3-ADECF7729AF7}" type="datetimeFigureOut">
               <a:rPr lang="en-US" smtClean="0"/>
-              <a:t>7/21/2026</a:t>
+              <a:t>7/22/2026</a:t>
             </a:fld>
             <a:endParaRPr lang="en-US"/>
           </a:p>
@@ -19270,7 +19441,7 @@
           <a:p>
             <a:fld id="{971AFA9C-17DA-4726-B9E3-ADECF7729AF7}" type="datetimeFigureOut">
               <a:rPr lang="en-US" smtClean="0"/>
-              <a:t>7/21/2026</a:t>
+              <a:t>7/22/2026</a:t>
             </a:fld>
             <a:endParaRPr lang="en-US"/>
           </a:p>
@@ -19399,7 +19570,7 @@
           <a:p>
             <a:fld id="{971AFA9C-17DA-4726-B9E3-ADECF7729AF7}" type="datetimeFigureOut">
               <a:rPr lang="en-US" smtClean="0"/>
-              <a:t>7/21/2026</a:t>
+              <a:t>7/22/2026</a:t>
             </a:fld>
             <a:endParaRPr lang="en-US"/>
           </a:p>
@@ -21194,7 +21365,7 @@
           <a:p>
             <a:fld id="{971AFA9C-17DA-4726-B9E3-ADECF7729AF7}" type="datetimeFigureOut">
               <a:rPr lang="en-US" smtClean="0"/>
-              <a:t>7/21/2026</a:t>
+              <a:t>7/22/2026</a:t>
             </a:fld>
             <a:endParaRPr lang="en-US"/>
           </a:p>
@@ -22760,7 +22931,7 @@
           <a:p>
             <a:fld id="{971AFA9C-17DA-4726-B9E3-ADECF7729AF7}" type="datetimeFigureOut">
               <a:rPr lang="en-US" smtClean="0"/>
-              <a:t>7/21/2026</a:t>
+              <a:t>7/22/2026</a:t>
             </a:fld>
             <a:endParaRPr lang="en-US"/>
           </a:p>
@@ -24567,7 +24738,7 @@
           <a:p>
             <a:fld id="{971AFA9C-17DA-4726-B9E3-ADECF7729AF7}" type="datetimeFigureOut">
               <a:rPr lang="en-US" smtClean="0"/>
-              <a:t>7/21/2026</a:t>
+              <a:t>7/22/2026</a:t>
             </a:fld>
             <a:endParaRPr lang="en-US"/>
           </a:p>
@@ -24816,7 +24987,7 @@
           <a:p>
             <a:fld id="{971AFA9C-17DA-4726-B9E3-ADECF7729AF7}" type="datetimeFigureOut">
               <a:rPr lang="en-US" smtClean="0"/>
-              <a:t>7/21/2026</a:t>
+              <a:t>7/22/2026</a:t>
             </a:fld>
             <a:endParaRPr lang="en-US"/>
           </a:p>
@@ -25122,7 +25293,7 @@
           <a:p>
             <a:fld id="{971AFA9C-17DA-4726-B9E3-ADECF7729AF7}" type="datetimeFigureOut">
               <a:rPr lang="en-US" smtClean="0"/>
-              <a:t>7/21/2026</a:t>
+              <a:t>7/22/2026</a:t>
             </a:fld>
             <a:endParaRPr lang="en-US"/>
           </a:p>
@@ -25323,7 +25494,7 @@
           <a:p>
             <a:fld id="{971AFA9C-17DA-4726-B9E3-ADECF7729AF7}" type="datetimeFigureOut">
               <a:rPr lang="en-US" smtClean="0"/>
-              <a:t>7/21/2026</a:t>
+              <a:t>7/22/2026</a:t>
             </a:fld>
             <a:endParaRPr lang="en-US"/>
           </a:p>
@@ -25811,7 +25982,7 @@
           <a:p>
             <a:fld id="{971AFA9C-17DA-4726-B9E3-ADECF7729AF7}" type="datetimeFigureOut">
               <a:rPr lang="en-US" smtClean="0"/>
-              <a:t>7/21/2026</a:t>
+              <a:t>7/22/2026</a:t>
             </a:fld>
             <a:endParaRPr lang="en-US"/>
           </a:p>
@@ -26447,7 +26618,7 @@
           <a:p>
             <a:fld id="{971AFA9C-17DA-4726-B9E3-ADECF7729AF7}" type="datetimeFigureOut">
               <a:rPr lang="en-US" smtClean="0"/>
-              <a:t>7/21/2026</a:t>
+              <a:t>7/22/2026</a:t>
             </a:fld>
             <a:endParaRPr lang="en-US"/>
           </a:p>
@@ -27504,7 +27675,7 @@
           <a:p>
             <a:fld id="{971AFA9C-17DA-4726-B9E3-ADECF7729AF7}" type="datetimeFigureOut">
               <a:rPr lang="en-US" smtClean="0"/>
-              <a:t>7/21/2026</a:t>
+              <a:t>7/22/2026</a:t>
             </a:fld>
             <a:endParaRPr lang="en-US"/>
           </a:p>
@@ -28540,7 +28711,7 @@
           <a:p>
             <a:fld id="{971AFA9C-17DA-4726-B9E3-ADECF7729AF7}" type="datetimeFigureOut">
               <a:rPr lang="en-US" smtClean="0"/>
-              <a:t>7/21/2026</a:t>
+              <a:t>7/22/2026</a:t>
             </a:fld>
             <a:endParaRPr lang="en-US"/>
           </a:p>
@@ -30236,7 +30407,7 @@
           <a:p>
             <a:fld id="{971AFA9C-17DA-4726-B9E3-ADECF7729AF7}" type="datetimeFigureOut">
               <a:rPr lang="en-US" smtClean="0"/>
-              <a:t>7/21/2026</a:t>
+              <a:t>7/22/2026</a:t>
             </a:fld>
             <a:endParaRPr lang="en-US"/>
           </a:p>
@@ -32039,7 +32210,7 @@
           <a:p>
             <a:fld id="{971AFA9C-17DA-4726-B9E3-ADECF7729AF7}" type="datetimeFigureOut">
               <a:rPr lang="en-US" smtClean="0"/>
-              <a:t>7/21/2026</a:t>
+              <a:t>7/22/2026</a:t>
             </a:fld>
             <a:endParaRPr lang="en-US"/>
           </a:p>
@@ -32217,7 +32388,7 @@
           <a:p>
             <a:fld id="{971AFA9C-17DA-4726-B9E3-ADECF7729AF7}" type="datetimeFigureOut">
               <a:rPr lang="en-US" smtClean="0"/>
-              <a:t>7/21/2026</a:t>
+              <a:t>7/22/2026</a:t>
             </a:fld>
             <a:endParaRPr lang="en-US"/>
           </a:p>
@@ -32443,7 +32614,7 @@
           <a:p>
             <a:fld id="{971AFA9C-17DA-4726-B9E3-ADECF7729AF7}" type="datetimeFigureOut">
               <a:rPr lang="en-US" smtClean="0"/>
-              <a:t>7/21/2026</a:t>
+              <a:t>7/22/2026</a:t>
             </a:fld>
             <a:endParaRPr lang="en-US"/>
           </a:p>
@@ -32732,7 +32903,7 @@
           <a:p>
             <a:fld id="{971AFA9C-17DA-4726-B9E3-ADECF7729AF7}" type="datetimeFigureOut">
               <a:rPr lang="en-US" smtClean="0"/>
-              <a:t>7/21/2026</a:t>
+              <a:t>7/22/2026</a:t>
             </a:fld>
             <a:endParaRPr lang="en-US"/>
           </a:p>
@@ -33343,7 +33514,7 @@
           <a:p>
             <a:fld id="{971AFA9C-17DA-4726-B9E3-ADECF7729AF7}" type="datetimeFigureOut">
               <a:rPr lang="en-US" smtClean="0"/>
-              <a:t>7/21/2026</a:t>
+              <a:t>7/22/2026</a:t>
             </a:fld>
             <a:endParaRPr lang="en-US"/>
           </a:p>
@@ -33619,7 +33790,7 @@
           <a:p>
             <a:fld id="{971AFA9C-17DA-4726-B9E3-ADECF7729AF7}" type="datetimeFigureOut">
               <a:rPr lang="en-US" smtClean="0"/>
-              <a:t>7/21/2026</a:t>
+              <a:t>7/22/2026</a:t>
             </a:fld>
             <a:endParaRPr lang="en-US"/>
           </a:p>
@@ -34476,7 +34647,7 @@
           <a:p>
             <a:fld id="{971AFA9C-17DA-4726-B9E3-ADECF7729AF7}" type="datetimeFigureOut">
               <a:rPr lang="en-US" smtClean="0"/>
-              <a:t>7/21/2026</a:t>
+              <a:t>7/22/2026</a:t>
             </a:fld>
             <a:endParaRPr lang="en-US"/>
           </a:p>
@@ -35578,7 +35749,7 @@
           <a:p>
             <a:fld id="{971AFA9C-17DA-4726-B9E3-ADECF7729AF7}" type="datetimeFigureOut">
               <a:rPr lang="en-US" smtClean="0"/>
-              <a:t>7/21/2026</a:t>
+              <a:t>7/22/2026</a:t>
             </a:fld>
             <a:endParaRPr lang="en-US"/>
           </a:p>
@@ -35866,7 +36037,7 @@
           <a:p>
             <a:fld id="{971AFA9C-17DA-4726-B9E3-ADECF7729AF7}" type="datetimeFigureOut">
               <a:rPr lang="en-US" smtClean="0"/>
-              <a:t>7/21/2026</a:t>
+              <a:t>7/22/2026</a:t>
             </a:fld>
             <a:endParaRPr lang="en-US"/>
           </a:p>
@@ -36339,7 +36510,7 @@
           <a:p>
             <a:fld id="{971AFA9C-17DA-4726-B9E3-ADECF7729AF7}" type="datetimeFigureOut">
               <a:rPr lang="en-US" smtClean="0"/>
-              <a:t>7/21/2026</a:t>
+              <a:t>7/22/2026</a:t>
             </a:fld>
             <a:endParaRPr lang="en-US"/>
           </a:p>
@@ -36651,7 +36822,7 @@
           <a:p>
             <a:fld id="{971AFA9C-17DA-4726-B9E3-ADECF7729AF7}" type="datetimeFigureOut">
               <a:rPr lang="en-US" smtClean="0"/>
-              <a:t>7/21/2026</a:t>
+              <a:t>7/22/2026</a:t>
             </a:fld>
             <a:endParaRPr lang="en-US"/>
           </a:p>
@@ -36929,7 +37100,7 @@
           <a:p>
             <a:fld id="{971AFA9C-17DA-4726-B9E3-ADECF7729AF7}" type="datetimeFigureOut">
               <a:rPr lang="en-US" smtClean="0"/>
-              <a:t>7/21/2026</a:t>
+              <a:t>7/22/2026</a:t>
             </a:fld>
             <a:endParaRPr lang="en-US"/>
           </a:p>
@@ -37207,7 +37378,7 @@
           <a:p>
             <a:fld id="{971AFA9C-17DA-4726-B9E3-ADECF7729AF7}" type="datetimeFigureOut">
               <a:rPr lang="en-US" smtClean="0"/>
-              <a:t>7/21/2026</a:t>
+              <a:t>7/22/2026</a:t>
             </a:fld>
             <a:endParaRPr lang="en-US"/>
           </a:p>
@@ -41561,7 +41732,7 @@
           <a:p>
             <a:fld id="{971AFA9C-17DA-4726-B9E3-ADECF7729AF7}" type="datetimeFigureOut">
               <a:rPr lang="en-US" smtClean="0"/>
-              <a:t>7/21/2026</a:t>
+              <a:t>7/22/2026</a:t>
             </a:fld>
             <a:endParaRPr lang="en-US"/>
           </a:p>
@@ -42077,7 +42248,7 @@
           <a:p>
             <a:fld id="{971AFA9C-17DA-4726-B9E3-ADECF7729AF7}" type="datetimeFigureOut">
               <a:rPr lang="en-US" smtClean="0"/>
-              <a:t>7/21/2026</a:t>
+              <a:t>7/22/2026</a:t>
             </a:fld>
             <a:endParaRPr lang="en-US"/>
           </a:p>
@@ -42761,7 +42932,7 @@
           <a:p>
             <a:fld id="{971AFA9C-17DA-4726-B9E3-ADECF7729AF7}" type="datetimeFigureOut">
               <a:rPr lang="en-US" smtClean="0"/>
-              <a:t>7/21/2026</a:t>
+              <a:t>7/22/2026</a:t>
             </a:fld>
             <a:endParaRPr lang="en-US"/>
           </a:p>
@@ -43854,7 +44025,7 @@
           <a:p>
             <a:fld id="{971AFA9C-17DA-4726-B9E3-ADECF7729AF7}" type="datetimeFigureOut">
               <a:rPr lang="en-US" smtClean="0"/>
-              <a:t>7/21/2026</a:t>
+              <a:t>7/22/2026</a:t>
             </a:fld>
             <a:endParaRPr lang="en-US"/>
           </a:p>
@@ -44800,7 +44971,7 @@
           <a:p>
             <a:fld id="{971AFA9C-17DA-4726-B9E3-ADECF7729AF7}" type="datetimeFigureOut">
               <a:rPr lang="en-US" smtClean="0"/>
-              <a:t>7/21/2026</a:t>
+              <a:t>7/22/2026</a:t>
             </a:fld>
             <a:endParaRPr lang="en-US"/>
           </a:p>
@@ -46905,7 +47076,7 @@
           </p:nvPr>
         </p:nvPicPr>
         <p:blipFill>
-          <a:blip r:embed="rId2"/>
+          <a:blip r:embed="rId3"/>
           <a:stretch>
             <a:fillRect/>
           </a:stretch>

</xml_diff>